<commit_message>
Añadir respuestas al debate y repaso del día 3 Módulo 4
- 2 slides con respuestas al debate (Lógica de negocio en chaincodes):
  lógica chaincode vs cliente, cambio de máquina de estados, Private Data
  y GDPR, registrador malicioso, gestión de roles en consorcio
- 2 slides con respuestas al repaso:
  verificación de identidad, GetMSPID vs AssertAttributeValue,
  máquina de estados, Private Data Collections, emisión de eventos,
  número máximo de eventos por transacción

Co-Authored-By: Claude Opus 4.6 (1M context) <noreply@anthropic.com>
</commit_message>
<xml_diff>
--- a/docs/slides/Modulo 4/dia_3.pptx
+++ b/docs/slides/Modulo 4/dia_3.pptx
@@ -25,6 +25,10 @@
     <p:sldId id="273" r:id="rId24"/>
     <p:sldId id="274" r:id="rId25"/>
     <p:sldId id="275" r:id="rId26"/>
+    <p:sldId id="276" r:id="rId27"/>
+    <p:sldId id="277" r:id="rId28"/>
+    <p:sldId id="278" r:id="rId29"/>
+    <p:sldId id="279" r:id="rId30"/>
   </p:sldIdLst>
   <p:sldSz cx="12188952" cy="6858000" type="screen4x3"/>
   <p:notesSz cx="6858000" cy="9144000"/>
@@ -6784,7 +6788,7 @@
         <p:spPr>
           <a:xfrm>
             <a:off x="0" y="0"/>
-            <a:ext cx="12188952" cy="6858000"/>
+            <a:ext cx="12188952" cy="73152"/>
           </a:xfrm>
           <a:prstGeom prst="rect">
             <a:avLst/>
@@ -6839,6 +6843,840 @@
           <a:lstStyle/>
           <a:p>
             <a:pPr algn="l">
+              <a:defRPr sz="3200" b="1">
+                <a:solidFill>
+                  <a:srgbClr val="22627E"/>
+                </a:solidFill>
+                <a:latin typeface="Calibri"/>
+              </a:defRPr>
+            </a:pPr>
+            <a:r>
+              <a:t>Respuestas al debate (1/2)</a:t>
+            </a:r>
+          </a:p>
+        </p:txBody>
+      </p:sp>
+      <p:sp>
+        <p:nvSpPr>
+          <p:cNvPr id="4" name="Rectangle 3"/>
+          <p:cNvSpPr/>
+          <p:nvPr/>
+        </p:nvSpPr>
+        <p:spPr>
+          <a:xfrm>
+            <a:off x="457200" y="1051560"/>
+            <a:ext cx="10972800" cy="27432"/>
+          </a:xfrm>
+          <a:prstGeom prst="rect">
+            <a:avLst/>
+          </a:prstGeom>
+          <a:solidFill>
+            <a:srgbClr val="22627E"/>
+          </a:solidFill>
+          <a:ln>
+            <a:noFill/>
+          </a:ln>
+        </p:spPr>
+        <p:style>
+          <a:lnRef idx="1">
+            <a:schemeClr val="accent1"/>
+          </a:lnRef>
+          <a:fillRef idx="3">
+            <a:schemeClr val="accent1"/>
+          </a:fillRef>
+          <a:effectRef idx="2">
+            <a:schemeClr val="accent1"/>
+          </a:effectRef>
+          <a:fontRef idx="minor">
+            <a:schemeClr val="lt1"/>
+          </a:fontRef>
+        </p:style>
+        <p:txBody>
+          <a:bodyPr rtlCol="0" anchor="ctr"/>
+          <a:lstStyle/>
+          <a:p>
+            <a:pPr algn="ctr"/>
+          </a:p>
+        </p:txBody>
+      </p:sp>
+      <p:sp>
+        <p:nvSpPr>
+          <p:cNvPr id="5" name="TextBox 4"/>
+          <p:cNvSpPr txBox="1"/>
+          <p:nvPr/>
+        </p:nvSpPr>
+        <p:spPr>
+          <a:xfrm>
+            <a:off x="640080" y="1280160"/>
+            <a:ext cx="10515600" cy="5029200"/>
+          </a:xfrm>
+          <a:prstGeom prst="rect">
+            <a:avLst/>
+          </a:prstGeom>
+          <a:noFill/>
+        </p:spPr>
+        <p:txBody>
+          <a:bodyPr wrap="square">
+            <a:spAutoFit/>
+          </a:bodyPr>
+          <a:lstStyle/>
+          <a:p>
+            <a:pPr>
+              <a:spcAft>
+                <a:spcPts val="800"/>
+              </a:spcAft>
+              <a:defRPr sz="2000">
+                <a:solidFill>
+                  <a:srgbClr val="333333"/>
+                </a:solidFill>
+                <a:latin typeface="Calibri"/>
+              </a:defRPr>
+            </a:pPr>
+            <a:r>
+              <a:t>1. Logica en chaincode vs app cliente:</a:t>
+            </a:r>
+          </a:p>
+          <a:p>
+            <a:pPr lvl="1">
+              <a:spcAft>
+                <a:spcPts val="400"/>
+              </a:spcAft>
+              <a:defRPr sz="1700">
+                <a:solidFill>
+                  <a:srgbClr val="666666"/>
+                </a:solidFill>
+                <a:latin typeface="Calibri"/>
+              </a:defRPr>
+            </a:pPr>
+            <a:r>
+              <a:t>    En el chaincode: reglas de negocio inmutables (saldos, permisos, transiciones validas).</a:t>
+            </a:r>
+          </a:p>
+          <a:p>
+            <a:pPr lvl="1">
+              <a:spcAft>
+                <a:spcPts val="400"/>
+              </a:spcAft>
+              <a:defRPr sz="1700">
+                <a:solidFill>
+                  <a:srgbClr val="666666"/>
+                </a:solidFill>
+                <a:latin typeface="Calibri"/>
+              </a:defRPr>
+            </a:pPr>
+            <a:r>
+              <a:t>    En el cliente: UI, orquestacion, validaciones de formato, UX.</a:t>
+            </a:r>
+          </a:p>
+          <a:p>
+            <a:pPr lvl="1">
+              <a:spcAft>
+                <a:spcPts val="400"/>
+              </a:spcAft>
+              <a:defRPr sz="1700">
+                <a:solidFill>
+                  <a:srgbClr val="666666"/>
+                </a:solidFill>
+                <a:latin typeface="Calibri"/>
+              </a:defRPr>
+            </a:pPr>
+            <a:r>
+              <a:t>    Regla: si se puede saltar desde otro cliente, NO es regla de negocio real.</a:t>
+            </a:r>
+          </a:p>
+          <a:p>
+            <a:pPr lvl="1">
+              <a:spcAft>
+                <a:spcPts val="400"/>
+              </a:spcAft>
+              <a:defRPr sz="1700">
+                <a:solidFill>
+                  <a:srgbClr val="666666"/>
+                </a:solidFill>
+                <a:latin typeface="Calibri"/>
+              </a:defRPr>
+            </a:pPr>
+            <a:r>
+              <a:t>    Si la regla afecta al ledger (consistencia entre todos los peers) -&gt; chaincode.</a:t>
+            </a:r>
+          </a:p>
+          <a:p>
+            <a:pPr>
+              <a:spcAft>
+                <a:spcPts val="800"/>
+              </a:spcAft>
+              <a:defRPr sz="2000">
+                <a:solidFill>
+                  <a:srgbClr val="333333"/>
+                </a:solidFill>
+                <a:latin typeface="Calibri"/>
+              </a:defRPr>
+            </a:pPr>
+            <a:r>
+              <a:t>2. Cambiar la maquina de estados despues del despliegue:</a:t>
+            </a:r>
+          </a:p>
+          <a:p>
+            <a:pPr lvl="1">
+              <a:spcAft>
+                <a:spcPts val="400"/>
+              </a:spcAft>
+              <a:defRPr sz="1700">
+                <a:solidFill>
+                  <a:srgbClr val="666666"/>
+                </a:solidFill>
+                <a:latin typeface="Calibri"/>
+              </a:defRPr>
+            </a:pPr>
+            <a:r>
+              <a:t>    Se despliega una nueva version del chaincode con sequence incrementado.</a:t>
+            </a:r>
+          </a:p>
+          <a:p>
+            <a:pPr lvl="1">
+              <a:spcAft>
+                <a:spcPts val="400"/>
+              </a:spcAft>
+              <a:defRPr sz="1700">
+                <a:solidFill>
+                  <a:srgbClr val="666666"/>
+                </a:solidFill>
+                <a:latin typeface="Calibri"/>
+              </a:defRPr>
+            </a:pPr>
+            <a:r>
+              <a:t>    El World State se preserva — los datos antiguos siguen ahi.</a:t>
+            </a:r>
+          </a:p>
+          <a:p>
+            <a:pPr lvl="1">
+              <a:spcAft>
+                <a:spcPts val="400"/>
+              </a:spcAft>
+              <a:defRPr sz="1700">
+                <a:solidFill>
+                  <a:srgbClr val="666666"/>
+                </a:solidFill>
+                <a:latin typeface="Calibri"/>
+              </a:defRPr>
+            </a:pPr>
+            <a:r>
+              <a:t>    Estrategias: anadir estados nuevos sin romper los antiguos (retrocompatibilidad).</a:t>
+            </a:r>
+          </a:p>
+          <a:p>
+            <a:pPr lvl="1">
+              <a:spcAft>
+                <a:spcPts val="400"/>
+              </a:spcAft>
+              <a:defRPr sz="1700">
+                <a:solidFill>
+                  <a:srgbClr val="666666"/>
+                </a:solidFill>
+                <a:latin typeface="Calibri"/>
+              </a:defRPr>
+            </a:pPr>
+            <a:r>
+              <a:t>    Si la transicion cambia radicalmente: migracion perezosa en cada lectura.</a:t>
+            </a:r>
+          </a:p>
+          <a:p>
+            <a:pPr lvl="1">
+              <a:spcAft>
+                <a:spcPts val="400"/>
+              </a:spcAft>
+              <a:defRPr sz="1700">
+                <a:solidFill>
+                  <a:srgbClr val="666666"/>
+                </a:solidFill>
+                <a:latin typeface="Calibri"/>
+              </a:defRPr>
+            </a:pPr>
+            <a:r>
+              <a:t>    Cuidado: nunca cambies el significado de un estado existente, crea uno nuevo.</a:t>
+            </a:r>
+          </a:p>
+          <a:p>
+            <a:pPr>
+              <a:spcAft>
+                <a:spcPts val="800"/>
+              </a:spcAft>
+              <a:defRPr sz="2000">
+                <a:solidFill>
+                  <a:srgbClr val="333333"/>
+                </a:solidFill>
+                <a:latin typeface="Calibri"/>
+              </a:defRPr>
+            </a:pPr>
+            <a:r>
+              <a:t>3. Private Data y GDPR:</a:t>
+            </a:r>
+          </a:p>
+          <a:p>
+            <a:pPr lvl="1">
+              <a:spcAft>
+                <a:spcPts val="400"/>
+              </a:spcAft>
+              <a:defRPr sz="1700">
+                <a:solidFill>
+                  <a:srgbClr val="666666"/>
+                </a:solidFill>
+                <a:latin typeface="Calibri"/>
+              </a:defRPr>
+            </a:pPr>
+            <a:r>
+              <a:t>    Private Data ayuda pero NO cumple GDPR por si solo.</a:t>
+            </a:r>
+          </a:p>
+          <a:p>
+            <a:pPr lvl="1">
+              <a:spcAft>
+                <a:spcPts val="400"/>
+              </a:spcAft>
+              <a:defRPr sz="1700">
+                <a:solidFill>
+                  <a:srgbClr val="666666"/>
+                </a:solidFill>
+                <a:latin typeface="Calibri"/>
+              </a:defRPr>
+            </a:pPr>
+            <a:r>
+              <a:t>    El hash queda on-chain para siempre (inmutable) — potencialmente trazable.</a:t>
+            </a:r>
+          </a:p>
+          <a:p>
+            <a:pPr lvl="1">
+              <a:spcAft>
+                <a:spcPts val="400"/>
+              </a:spcAft>
+              <a:defRPr sz="1700">
+                <a:solidFill>
+                  <a:srgbClr val="666666"/>
+                </a:solidFill>
+                <a:latin typeface="Calibri"/>
+              </a:defRPr>
+            </a:pPr>
+            <a:r>
+              <a:t>    blockToLive permite caducar datos privados, pero el hash sigue.</a:t>
+            </a:r>
+          </a:p>
+          <a:p>
+            <a:pPr lvl="1">
+              <a:spcAft>
+                <a:spcPts val="400"/>
+              </a:spcAft>
+              <a:defRPr sz="1700">
+                <a:solidFill>
+                  <a:srgbClr val="666666"/>
+                </a:solidFill>
+                <a:latin typeface="Calibri"/>
+              </a:defRPr>
+            </a:pPr>
+            <a:r>
+              <a:t>    Mejor practica: datos personales OFF-CHAIN, solo hash/referencia on-chain.</a:t>
+            </a:r>
+          </a:p>
+          <a:p>
+            <a:pPr lvl="1">
+              <a:spcAft>
+                <a:spcPts val="400"/>
+              </a:spcAft>
+              <a:defRPr sz="1700">
+                <a:solidFill>
+                  <a:srgbClr val="666666"/>
+                </a:solidFill>
+                <a:latin typeface="Calibri"/>
+              </a:defRPr>
+            </a:pPr>
+            <a:r>
+              <a:t>    Cuando borras el dato off-chain, el hash on-chain queda huerfano (pseudonimizacion efectiva).</a:t>
+            </a:r>
+          </a:p>
+        </p:txBody>
+      </p:sp>
+    </p:spTree>
+  </p:cSld>
+  <p:clrMapOvr>
+    <a:masterClrMapping/>
+  </p:clrMapOvr>
+</p:sld>
+</file>
+
+<file path=ppt/slides/slide21.xml><?xml version="1.0" encoding="utf-8"?>
+<p:sld xmlns:a="http://schemas.openxmlformats.org/drawingml/2006/main" xmlns:p="http://schemas.openxmlformats.org/presentationml/2006/main" xmlns:r="http://schemas.openxmlformats.org/officeDocument/2006/relationships">
+  <p:cSld>
+    <p:spTree>
+      <p:nvGrpSpPr>
+        <p:cNvPr id="1" name=""/>
+        <p:cNvGrpSpPr/>
+        <p:nvPr/>
+      </p:nvGrpSpPr>
+      <p:grpSpPr/>
+      <p:sp>
+        <p:nvSpPr>
+          <p:cNvPr id="2" name="Rectangle 1"/>
+          <p:cNvSpPr/>
+          <p:nvPr/>
+        </p:nvSpPr>
+        <p:spPr>
+          <a:xfrm>
+            <a:off x="0" y="0"/>
+            <a:ext cx="12188952" cy="73152"/>
+          </a:xfrm>
+          <a:prstGeom prst="rect">
+            <a:avLst/>
+          </a:prstGeom>
+          <a:solidFill>
+            <a:srgbClr val="22627E"/>
+          </a:solidFill>
+          <a:ln>
+            <a:noFill/>
+          </a:ln>
+        </p:spPr>
+        <p:style>
+          <a:lnRef idx="1">
+            <a:schemeClr val="accent1"/>
+          </a:lnRef>
+          <a:fillRef idx="3">
+            <a:schemeClr val="accent1"/>
+          </a:fillRef>
+          <a:effectRef idx="2">
+            <a:schemeClr val="accent1"/>
+          </a:effectRef>
+          <a:fontRef idx="minor">
+            <a:schemeClr val="lt1"/>
+          </a:fontRef>
+        </p:style>
+        <p:txBody>
+          <a:bodyPr rtlCol="0" anchor="ctr"/>
+          <a:lstStyle/>
+          <a:p>
+            <a:pPr algn="ctr"/>
+          </a:p>
+        </p:txBody>
+      </p:sp>
+      <p:sp>
+        <p:nvSpPr>
+          <p:cNvPr id="3" name="TextBox 2"/>
+          <p:cNvSpPr txBox="1"/>
+          <p:nvPr/>
+        </p:nvSpPr>
+        <p:spPr>
+          <a:xfrm>
+            <a:off x="457200" y="274320"/>
+            <a:ext cx="10972800" cy="731520"/>
+          </a:xfrm>
+          <a:prstGeom prst="rect">
+            <a:avLst/>
+          </a:prstGeom>
+          <a:noFill/>
+        </p:spPr>
+        <p:txBody>
+          <a:bodyPr wrap="square"/>
+          <a:lstStyle/>
+          <a:p>
+            <a:pPr algn="l">
+              <a:defRPr sz="3200" b="1">
+                <a:solidFill>
+                  <a:srgbClr val="22627E"/>
+                </a:solidFill>
+                <a:latin typeface="Calibri"/>
+              </a:defRPr>
+            </a:pPr>
+            <a:r>
+              <a:t>Respuestas al debate (2/2)</a:t>
+            </a:r>
+          </a:p>
+        </p:txBody>
+      </p:sp>
+      <p:sp>
+        <p:nvSpPr>
+          <p:cNvPr id="4" name="Rectangle 3"/>
+          <p:cNvSpPr/>
+          <p:nvPr/>
+        </p:nvSpPr>
+        <p:spPr>
+          <a:xfrm>
+            <a:off x="457200" y="1051560"/>
+            <a:ext cx="10972800" cy="27432"/>
+          </a:xfrm>
+          <a:prstGeom prst="rect">
+            <a:avLst/>
+          </a:prstGeom>
+          <a:solidFill>
+            <a:srgbClr val="22627E"/>
+          </a:solidFill>
+          <a:ln>
+            <a:noFill/>
+          </a:ln>
+        </p:spPr>
+        <p:style>
+          <a:lnRef idx="1">
+            <a:schemeClr val="accent1"/>
+          </a:lnRef>
+          <a:fillRef idx="3">
+            <a:schemeClr val="accent1"/>
+          </a:fillRef>
+          <a:effectRef idx="2">
+            <a:schemeClr val="accent1"/>
+          </a:effectRef>
+          <a:fontRef idx="minor">
+            <a:schemeClr val="lt1"/>
+          </a:fontRef>
+        </p:style>
+        <p:txBody>
+          <a:bodyPr rtlCol="0" anchor="ctr"/>
+          <a:lstStyle/>
+          <a:p>
+            <a:pPr algn="ctr"/>
+          </a:p>
+        </p:txBody>
+      </p:sp>
+      <p:sp>
+        <p:nvSpPr>
+          <p:cNvPr id="5" name="TextBox 4"/>
+          <p:cNvSpPr txBox="1"/>
+          <p:nvPr/>
+        </p:nvSpPr>
+        <p:spPr>
+          <a:xfrm>
+            <a:off x="640080" y="1280160"/>
+            <a:ext cx="10515600" cy="5029200"/>
+          </a:xfrm>
+          <a:prstGeom prst="rect">
+            <a:avLst/>
+          </a:prstGeom>
+          <a:noFill/>
+        </p:spPr>
+        <p:txBody>
+          <a:bodyPr wrap="square">
+            <a:spAutoFit/>
+          </a:bodyPr>
+          <a:lstStyle/>
+          <a:p>
+            <a:pPr>
+              <a:spcAft>
+                <a:spcPts val="800"/>
+              </a:spcAft>
+              <a:defRPr sz="2000">
+                <a:solidFill>
+                  <a:srgbClr val="333333"/>
+                </a:solidFill>
+                <a:latin typeface="Calibri"/>
+              </a:defRPr>
+            </a:pPr>
+            <a:r>
+              <a:t>4. Registrador malicioso confirma transferencias falsas:</a:t>
+            </a:r>
+          </a:p>
+          <a:p>
+            <a:pPr lvl="1">
+              <a:spcAft>
+                <a:spcPts val="400"/>
+              </a:spcAft>
+              <a:defRPr sz="1700">
+                <a:solidFill>
+                  <a:srgbClr val="666666"/>
+                </a:solidFill>
+                <a:latin typeface="Calibri"/>
+              </a:defRPr>
+            </a:pPr>
+            <a:r>
+              <a:t>    El chaincode por si solo no lo evita — solo valida que tiene el atributo 'role=registrador'.</a:t>
+            </a:r>
+          </a:p>
+          <a:p>
+            <a:pPr lvl="1">
+              <a:spcAft>
+                <a:spcPts val="400"/>
+              </a:spcAft>
+              <a:defRPr sz="1700">
+                <a:solidFill>
+                  <a:srgbClr val="666666"/>
+                </a:solidFill>
+                <a:latin typeface="Calibri"/>
+              </a:defRPr>
+            </a:pPr>
+            <a:r>
+              <a:t>    Mitigaciones en capas:</a:t>
+            </a:r>
+          </a:p>
+          <a:p>
+            <a:pPr lvl="1">
+              <a:spcAft>
+                <a:spcPts val="400"/>
+              </a:spcAft>
+              <a:defRPr sz="1700">
+                <a:solidFill>
+                  <a:srgbClr val="666666"/>
+                </a:solidFill>
+                <a:latin typeface="Calibri"/>
+              </a:defRPr>
+            </a:pPr>
+            <a:r>
+              <a:t>      a) Multi-firma: transferencias criticas requieren N de M registradores (endorsement policy).</a:t>
+            </a:r>
+          </a:p>
+          <a:p>
+            <a:pPr lvl="1">
+              <a:spcAft>
+                <a:spcPts val="400"/>
+              </a:spcAft>
+              <a:defRPr sz="1700">
+                <a:solidFill>
+                  <a:srgbClr val="666666"/>
+                </a:solidFill>
+                <a:latin typeface="Calibri"/>
+              </a:defRPr>
+            </a:pPr>
+            <a:r>
+              <a:t>      b) Auditoria externa: un rol 'auditor' revisa transacciones periodicamente.</a:t>
+            </a:r>
+          </a:p>
+          <a:p>
+            <a:pPr lvl="1">
+              <a:spcAft>
+                <a:spcPts val="400"/>
+              </a:spcAft>
+              <a:defRPr sz="1700">
+                <a:solidFill>
+                  <a:srgbClr val="666666"/>
+                </a:solidFill>
+                <a:latin typeface="Calibri"/>
+              </a:defRPr>
+            </a:pPr>
+            <a:r>
+              <a:t>      c) Jurisdiccion legal: el certificado identifica a la persona, responsabilidad penal.</a:t>
+            </a:r>
+          </a:p>
+          <a:p>
+            <a:pPr lvl="1">
+              <a:spcAft>
+                <a:spcPts val="400"/>
+              </a:spcAft>
+              <a:defRPr sz="1700">
+                <a:solidFill>
+                  <a:srgbClr val="666666"/>
+                </a:solidFill>
+                <a:latin typeface="Calibri"/>
+              </a:defRPr>
+            </a:pPr>
+            <a:r>
+              <a:t>      d) Revocacion rapida del certificado si se detecta fraude + CRL actualizada.</a:t>
+            </a:r>
+          </a:p>
+          <a:p>
+            <a:pPr lvl="1">
+              <a:spcAft>
+                <a:spcPts val="400"/>
+              </a:spcAft>
+              <a:defRPr sz="1700">
+                <a:solidFill>
+                  <a:srgbClr val="666666"/>
+                </a:solidFill>
+                <a:latin typeface="Calibri"/>
+              </a:defRPr>
+            </a:pPr>
+            <a:r>
+              <a:t>    Ningun sistema es 100% a prueba de insider malicioso; blockchain reduce pero no elimina.</a:t>
+            </a:r>
+          </a:p>
+          <a:p>
+            <a:pPr>
+              <a:spcAft>
+                <a:spcPts val="800"/>
+              </a:spcAft>
+              <a:defRPr sz="2000">
+                <a:solidFill>
+                  <a:srgbClr val="333333"/>
+                </a:solidFill>
+                <a:latin typeface="Calibri"/>
+              </a:defRPr>
+            </a:pPr>
+            <a:r>
+              <a:t>5. Gestion de roles (registrador, autoridad) en un consorcio real:</a:t>
+            </a:r>
+          </a:p>
+          <a:p>
+            <a:pPr lvl="1">
+              <a:spcAft>
+                <a:spcPts val="400"/>
+              </a:spcAft>
+              <a:defRPr sz="1700">
+                <a:solidFill>
+                  <a:srgbClr val="666666"/>
+                </a:solidFill>
+                <a:latin typeface="Calibri"/>
+              </a:defRPr>
+            </a:pPr>
+            <a:r>
+              <a:t>    Registrar los roles como atributos del certificado X.509 via Fabric CA.</a:t>
+            </a:r>
+          </a:p>
+          <a:p>
+            <a:pPr lvl="1">
+              <a:spcAft>
+                <a:spcPts val="400"/>
+              </a:spcAft>
+              <a:defRPr sz="1700">
+                <a:solidFill>
+                  <a:srgbClr val="666666"/>
+                </a:solidFill>
+                <a:latin typeface="Calibri"/>
+              </a:defRPr>
+            </a:pPr>
+            <a:r>
+              <a:t>    Separacion de funciones: quien otorga el rol NO puede usarlo.</a:t>
+            </a:r>
+          </a:p>
+          <a:p>
+            <a:pPr lvl="1">
+              <a:spcAft>
+                <a:spcPts val="400"/>
+              </a:spcAft>
+              <a:defRPr sz="1700">
+                <a:solidFill>
+                  <a:srgbClr val="666666"/>
+                </a:solidFill>
+                <a:latin typeface="Calibri"/>
+              </a:defRPr>
+            </a:pPr>
+            <a:r>
+              <a:t>    Rotacion de roles: no dejar eternamente al mismo usuario con privilegios.</a:t>
+            </a:r>
+          </a:p>
+          <a:p>
+            <a:pPr lvl="1">
+              <a:spcAft>
+                <a:spcPts val="400"/>
+              </a:spcAft>
+              <a:defRPr sz="1700">
+                <a:solidFill>
+                  <a:srgbClr val="666666"/>
+                </a:solidFill>
+                <a:latin typeface="Calibri"/>
+              </a:defRPr>
+            </a:pPr>
+            <a:r>
+              <a:t>    Gobernanza clara: documento del consorcio define quien puede asignar cada rol.</a:t>
+            </a:r>
+          </a:p>
+          <a:p>
+            <a:pPr lvl="1">
+              <a:spcAft>
+                <a:spcPts val="400"/>
+              </a:spcAft>
+              <a:defRPr sz="1700">
+                <a:solidFill>
+                  <a:srgbClr val="666666"/>
+                </a:solidFill>
+                <a:latin typeface="Calibri"/>
+              </a:defRPr>
+            </a:pPr>
+            <a:r>
+              <a:t>    Logs de auditoria: cada emisin/revocacion de rol queda registrada en Fabric CA.</a:t>
+            </a:r>
+          </a:p>
+          <a:p>
+            <a:pPr lvl="1">
+              <a:spcAft>
+                <a:spcPts val="400"/>
+              </a:spcAft>
+              <a:defRPr sz="1700">
+                <a:solidFill>
+                  <a:srgbClr val="666666"/>
+                </a:solidFill>
+                <a:latin typeface="Calibri"/>
+              </a:defRPr>
+            </a:pPr>
+            <a:r>
+              <a:t>    Reglas en el chaincode: un rol solo puede hacer ciertas operaciones (ABAC).</a:t>
+            </a:r>
+          </a:p>
+        </p:txBody>
+      </p:sp>
+    </p:spTree>
+  </p:cSld>
+  <p:clrMapOvr>
+    <a:masterClrMapping/>
+  </p:clrMapOvr>
+</p:sld>
+</file>
+
+<file path=ppt/slides/slide22.xml><?xml version="1.0" encoding="utf-8"?>
+<p:sld xmlns:a="http://schemas.openxmlformats.org/drawingml/2006/main" xmlns:p="http://schemas.openxmlformats.org/presentationml/2006/main" xmlns:r="http://schemas.openxmlformats.org/officeDocument/2006/relationships">
+  <p:cSld>
+    <p:spTree>
+      <p:nvGrpSpPr>
+        <p:cNvPr id="1" name=""/>
+        <p:cNvGrpSpPr/>
+        <p:nvPr/>
+      </p:nvGrpSpPr>
+      <p:grpSpPr/>
+      <p:sp>
+        <p:nvSpPr>
+          <p:cNvPr id="2" name="Rectangle 1"/>
+          <p:cNvSpPr/>
+          <p:nvPr/>
+        </p:nvSpPr>
+        <p:spPr>
+          <a:xfrm>
+            <a:off x="0" y="0"/>
+            <a:ext cx="12188952" cy="6858000"/>
+          </a:xfrm>
+          <a:prstGeom prst="rect">
+            <a:avLst/>
+          </a:prstGeom>
+          <a:solidFill>
+            <a:srgbClr val="22627E"/>
+          </a:solidFill>
+          <a:ln>
+            <a:noFill/>
+          </a:ln>
+        </p:spPr>
+        <p:style>
+          <a:lnRef idx="1">
+            <a:schemeClr val="accent1"/>
+          </a:lnRef>
+          <a:fillRef idx="3">
+            <a:schemeClr val="accent1"/>
+          </a:fillRef>
+          <a:effectRef idx="2">
+            <a:schemeClr val="accent1"/>
+          </a:effectRef>
+          <a:fontRef idx="minor">
+            <a:schemeClr val="lt1"/>
+          </a:fontRef>
+        </p:style>
+        <p:txBody>
+          <a:bodyPr rtlCol="0" anchor="ctr"/>
+          <a:lstStyle/>
+          <a:p>
+            <a:pPr algn="ctr"/>
+          </a:p>
+        </p:txBody>
+      </p:sp>
+      <p:sp>
+        <p:nvSpPr>
+          <p:cNvPr id="3" name="TextBox 2"/>
+          <p:cNvSpPr txBox="1"/>
+          <p:nvPr/>
+        </p:nvSpPr>
+        <p:spPr>
+          <a:xfrm>
+            <a:off x="457200" y="274320"/>
+            <a:ext cx="10972800" cy="731520"/>
+          </a:xfrm>
+          <a:prstGeom prst="rect">
+            <a:avLst/>
+          </a:prstGeom>
+          <a:noFill/>
+        </p:spPr>
+        <p:txBody>
+          <a:bodyPr wrap="square"/>
+          <a:lstStyle/>
+          <a:p>
+            <a:pPr algn="l">
               <a:defRPr sz="3600" b="1">
                 <a:solidFill>
                   <a:srgbClr val="FFFFFF"/>
@@ -7026,6 +7864,824 @@
             </a:pPr>
             <a:r>
               <a:t>7. ¿Cuantos eventos se pueden emitir por transaccion?</a:t>
+            </a:r>
+          </a:p>
+        </p:txBody>
+      </p:sp>
+    </p:spTree>
+  </p:cSld>
+  <p:clrMapOvr>
+    <a:masterClrMapping/>
+  </p:clrMapOvr>
+</p:sld>
+</file>
+
+<file path=ppt/slides/slide23.xml><?xml version="1.0" encoding="utf-8"?>
+<p:sld xmlns:a="http://schemas.openxmlformats.org/drawingml/2006/main" xmlns:p="http://schemas.openxmlformats.org/presentationml/2006/main" xmlns:r="http://schemas.openxmlformats.org/officeDocument/2006/relationships">
+  <p:cSld>
+    <p:spTree>
+      <p:nvGrpSpPr>
+        <p:cNvPr id="1" name=""/>
+        <p:cNvGrpSpPr/>
+        <p:nvPr/>
+      </p:nvGrpSpPr>
+      <p:grpSpPr/>
+      <p:sp>
+        <p:nvSpPr>
+          <p:cNvPr id="2" name="Rectangle 1"/>
+          <p:cNvSpPr/>
+          <p:nvPr/>
+        </p:nvSpPr>
+        <p:spPr>
+          <a:xfrm>
+            <a:off x="0" y="0"/>
+            <a:ext cx="12188952" cy="73152"/>
+          </a:xfrm>
+          <a:prstGeom prst="rect">
+            <a:avLst/>
+          </a:prstGeom>
+          <a:solidFill>
+            <a:srgbClr val="22627E"/>
+          </a:solidFill>
+          <a:ln>
+            <a:noFill/>
+          </a:ln>
+        </p:spPr>
+        <p:style>
+          <a:lnRef idx="1">
+            <a:schemeClr val="accent1"/>
+          </a:lnRef>
+          <a:fillRef idx="3">
+            <a:schemeClr val="accent1"/>
+          </a:fillRef>
+          <a:effectRef idx="2">
+            <a:schemeClr val="accent1"/>
+          </a:effectRef>
+          <a:fontRef idx="minor">
+            <a:schemeClr val="lt1"/>
+          </a:fontRef>
+        </p:style>
+        <p:txBody>
+          <a:bodyPr rtlCol="0" anchor="ctr"/>
+          <a:lstStyle/>
+          <a:p>
+            <a:pPr algn="ctr"/>
+          </a:p>
+        </p:txBody>
+      </p:sp>
+      <p:sp>
+        <p:nvSpPr>
+          <p:cNvPr id="3" name="TextBox 2"/>
+          <p:cNvSpPr txBox="1"/>
+          <p:nvPr/>
+        </p:nvSpPr>
+        <p:spPr>
+          <a:xfrm>
+            <a:off x="457200" y="274320"/>
+            <a:ext cx="10972800" cy="731520"/>
+          </a:xfrm>
+          <a:prstGeom prst="rect">
+            <a:avLst/>
+          </a:prstGeom>
+          <a:noFill/>
+        </p:spPr>
+        <p:txBody>
+          <a:bodyPr wrap="square"/>
+          <a:lstStyle/>
+          <a:p>
+            <a:pPr algn="l">
+              <a:defRPr sz="3200" b="1">
+                <a:solidFill>
+                  <a:srgbClr val="22627E"/>
+                </a:solidFill>
+                <a:latin typeface="Calibri"/>
+              </a:defRPr>
+            </a:pPr>
+            <a:r>
+              <a:t>Respuestas al repaso (1/2)</a:t>
+            </a:r>
+          </a:p>
+        </p:txBody>
+      </p:sp>
+      <p:sp>
+        <p:nvSpPr>
+          <p:cNvPr id="4" name="Rectangle 3"/>
+          <p:cNvSpPr/>
+          <p:nvPr/>
+        </p:nvSpPr>
+        <p:spPr>
+          <a:xfrm>
+            <a:off x="457200" y="1051560"/>
+            <a:ext cx="10972800" cy="27432"/>
+          </a:xfrm>
+          <a:prstGeom prst="rect">
+            <a:avLst/>
+          </a:prstGeom>
+          <a:solidFill>
+            <a:srgbClr val="22627E"/>
+          </a:solidFill>
+          <a:ln>
+            <a:noFill/>
+          </a:ln>
+        </p:spPr>
+        <p:style>
+          <a:lnRef idx="1">
+            <a:schemeClr val="accent1"/>
+          </a:lnRef>
+          <a:fillRef idx="3">
+            <a:schemeClr val="accent1"/>
+          </a:fillRef>
+          <a:effectRef idx="2">
+            <a:schemeClr val="accent1"/>
+          </a:effectRef>
+          <a:fontRef idx="minor">
+            <a:schemeClr val="lt1"/>
+          </a:fontRef>
+        </p:style>
+        <p:txBody>
+          <a:bodyPr rtlCol="0" anchor="ctr"/>
+          <a:lstStyle/>
+          <a:p>
+            <a:pPr algn="ctr"/>
+          </a:p>
+        </p:txBody>
+      </p:sp>
+      <p:sp>
+        <p:nvSpPr>
+          <p:cNvPr id="5" name="TextBox 4"/>
+          <p:cNvSpPr txBox="1"/>
+          <p:nvPr/>
+        </p:nvSpPr>
+        <p:spPr>
+          <a:xfrm>
+            <a:off x="640080" y="1280160"/>
+            <a:ext cx="10515600" cy="5029200"/>
+          </a:xfrm>
+          <a:prstGeom prst="rect">
+            <a:avLst/>
+          </a:prstGeom>
+          <a:noFill/>
+        </p:spPr>
+        <p:txBody>
+          <a:bodyPr wrap="square">
+            <a:spAutoFit/>
+          </a:bodyPr>
+          <a:lstStyle/>
+          <a:p>
+            <a:pPr>
+              <a:spcAft>
+                <a:spcPts val="800"/>
+              </a:spcAft>
+              <a:defRPr sz="2000">
+                <a:solidFill>
+                  <a:srgbClr val="333333"/>
+                </a:solidFill>
+                <a:latin typeface="Calibri"/>
+              </a:defRPr>
+            </a:pPr>
+            <a:r>
+              <a:t>1. Verificacion de identidad en un chaincode:</a:t>
+            </a:r>
+          </a:p>
+          <a:p>
+            <a:pPr lvl="1">
+              <a:spcAft>
+                <a:spcPts val="400"/>
+              </a:spcAft>
+              <a:defRPr sz="1700">
+                <a:solidFill>
+                  <a:srgbClr val="666666"/>
+                </a:solidFill>
+                <a:latin typeface="Calibri"/>
+              </a:defRPr>
+            </a:pPr>
+            <a:r>
+              <a:t>    A traves de ctx.GetClientIdentity(), que devuelve datos del certificado X.509 del caller.</a:t>
+            </a:r>
+          </a:p>
+          <a:p>
+            <a:pPr lvl="1">
+              <a:spcAft>
+                <a:spcPts val="400"/>
+              </a:spcAft>
+              <a:defRPr sz="1700">
+                <a:solidFill>
+                  <a:srgbClr val="666666"/>
+                </a:solidFill>
+                <a:latin typeface="Calibri"/>
+              </a:defRPr>
+            </a:pPr>
+            <a:r>
+              <a:t>    Metodos principales: GetID, GetMSPID, GetAttributeValue, AssertAttributeValue.</a:t>
+            </a:r>
+          </a:p>
+          <a:p>
+            <a:pPr lvl="1">
+              <a:spcAft>
+                <a:spcPts val="400"/>
+              </a:spcAft>
+              <a:defRPr sz="1700">
+                <a:solidFill>
+                  <a:srgbClr val="666666"/>
+                </a:solidFill>
+                <a:latin typeface="Calibri"/>
+              </a:defRPr>
+            </a:pPr>
+            <a:r>
+              <a:t>    El peer YA ha validado el certificado antes de llamar al chaincode (no tienes que validarlo tu).</a:t>
+            </a:r>
+          </a:p>
+          <a:p>
+            <a:pPr lvl="1">
+              <a:spcAft>
+                <a:spcPts val="400"/>
+              </a:spcAft>
+              <a:defRPr sz="1700">
+                <a:solidFill>
+                  <a:srgbClr val="666666"/>
+                </a:solidFill>
+                <a:latin typeface="Calibri"/>
+              </a:defRPr>
+            </a:pPr>
+            <a:r>
+              <a:t>    Tu trabajo es decidir si ese cert autenticado puede hacer lo que pide (autorizacion).</a:t>
+            </a:r>
+          </a:p>
+          <a:p>
+            <a:pPr>
+              <a:spcAft>
+                <a:spcPts val="800"/>
+              </a:spcAft>
+              <a:defRPr sz="2000">
+                <a:solidFill>
+                  <a:srgbClr val="333333"/>
+                </a:solidFill>
+                <a:latin typeface="Calibri"/>
+              </a:defRPr>
+            </a:pPr>
+            <a:r>
+              <a:t>2. GetMSPID() vs AssertAttributeValue():</a:t>
+            </a:r>
+          </a:p>
+          <a:p>
+            <a:pPr lvl="1">
+              <a:spcAft>
+                <a:spcPts val="400"/>
+              </a:spcAft>
+              <a:defRPr sz="1700">
+                <a:solidFill>
+                  <a:srgbClr val="666666"/>
+                </a:solidFill>
+                <a:latin typeface="Calibri"/>
+              </a:defRPr>
+            </a:pPr>
+            <a:r>
+              <a:t>    GetMSPID(): devuelve la organizacion del caller ('Org1MSP', 'HotelMSP'...).</a:t>
+            </a:r>
+          </a:p>
+          <a:p>
+            <a:pPr lvl="1">
+              <a:spcAft>
+                <a:spcPts val="400"/>
+              </a:spcAft>
+              <a:defRPr sz="1700">
+                <a:solidFill>
+                  <a:srgbClr val="666666"/>
+                </a:solidFill>
+                <a:latin typeface="Calibri"/>
+              </a:defRPr>
+            </a:pPr>
+            <a:r>
+              <a:t>    AssertAttributeValue(attr, value): comprueba un atributo custom del cert (devuelve error si no coincide).</a:t>
+            </a:r>
+          </a:p>
+          <a:p>
+            <a:pPr lvl="1">
+              <a:spcAft>
+                <a:spcPts val="400"/>
+              </a:spcAft>
+              <a:defRPr sz="1700">
+                <a:solidFill>
+                  <a:srgbClr val="666666"/>
+                </a:solidFill>
+                <a:latin typeface="Calibri"/>
+              </a:defRPr>
+            </a:pPr>
+            <a:r>
+              <a:t>    GetMSPID: para controlar QUE ORG llama (Hotel vs Cafeteria).</a:t>
+            </a:r>
+          </a:p>
+          <a:p>
+            <a:pPr lvl="1">
+              <a:spcAft>
+                <a:spcPts val="400"/>
+              </a:spcAft>
+              <a:defRPr sz="1700">
+                <a:solidFill>
+                  <a:srgbClr val="666666"/>
+                </a:solidFill>
+                <a:latin typeface="Calibri"/>
+              </a:defRPr>
+            </a:pPr>
+            <a:r>
+              <a:t>    AssertAttributeValue: para controlar QUE ROL tiene (registrador, auditor, admin).</a:t>
+            </a:r>
+          </a:p>
+          <a:p>
+            <a:pPr>
+              <a:spcAft>
+                <a:spcPts val="800"/>
+              </a:spcAft>
+              <a:defRPr sz="2000">
+                <a:solidFill>
+                  <a:srgbClr val="333333"/>
+                </a:solidFill>
+                <a:latin typeface="Calibri"/>
+              </a:defRPr>
+            </a:pPr>
+            <a:r>
+              <a:t>3. Maquina de estados en chaincodes:</a:t>
+            </a:r>
+          </a:p>
+          <a:p>
+            <a:pPr lvl="1">
+              <a:spcAft>
+                <a:spcPts val="400"/>
+              </a:spcAft>
+              <a:defRPr sz="1700">
+                <a:solidFill>
+                  <a:srgbClr val="666666"/>
+                </a:solidFill>
+                <a:latin typeface="Calibri"/>
+              </a:defRPr>
+            </a:pPr>
+            <a:r>
+              <a:t>    Conjunto de estados validos y transiciones permitidas entre ellos.</a:t>
+            </a:r>
+          </a:p>
+          <a:p>
+            <a:pPr lvl="1">
+              <a:spcAft>
+                <a:spcPts val="400"/>
+              </a:spcAft>
+              <a:defRPr sz="1700">
+                <a:solidFill>
+                  <a:srgbClr val="666666"/>
+                </a:solidFill>
+                <a:latin typeface="Calibri"/>
+              </a:defRPr>
+            </a:pPr>
+            <a:r>
+              <a:t>    Ejemplo propiedad: active -&gt; transferring -&gt; active | blocked.</a:t>
+            </a:r>
+          </a:p>
+          <a:p>
+            <a:pPr lvl="1">
+              <a:spcAft>
+                <a:spcPts val="400"/>
+              </a:spcAft>
+              <a:defRPr sz="1700">
+                <a:solidFill>
+                  <a:srgbClr val="666666"/>
+                </a:solidFill>
+                <a:latin typeface="Calibri"/>
+              </a:defRPr>
+            </a:pPr>
+            <a:r>
+              <a:t>    Util para: evitar estados imposibles, forzar orden correcto, claridad del dominio.</a:t>
+            </a:r>
+          </a:p>
+          <a:p>
+            <a:pPr lvl="1">
+              <a:spcAft>
+                <a:spcPts val="400"/>
+              </a:spcAft>
+              <a:defRPr sz="1700">
+                <a:solidFill>
+                  <a:srgbClr val="666666"/>
+                </a:solidFill>
+                <a:latin typeface="Calibri"/>
+              </a:defRPr>
+            </a:pPr>
+            <a:r>
+              <a:t>    Implementacion: validar en cada funcion 'if currentStatus != X return error'.</a:t>
+            </a:r>
+          </a:p>
+        </p:txBody>
+      </p:sp>
+    </p:spTree>
+  </p:cSld>
+  <p:clrMapOvr>
+    <a:masterClrMapping/>
+  </p:clrMapOvr>
+</p:sld>
+</file>
+
+<file path=ppt/slides/slide24.xml><?xml version="1.0" encoding="utf-8"?>
+<p:sld xmlns:a="http://schemas.openxmlformats.org/drawingml/2006/main" xmlns:p="http://schemas.openxmlformats.org/presentationml/2006/main" xmlns:r="http://schemas.openxmlformats.org/officeDocument/2006/relationships">
+  <p:cSld>
+    <p:spTree>
+      <p:nvGrpSpPr>
+        <p:cNvPr id="1" name=""/>
+        <p:cNvGrpSpPr/>
+        <p:nvPr/>
+      </p:nvGrpSpPr>
+      <p:grpSpPr/>
+      <p:sp>
+        <p:nvSpPr>
+          <p:cNvPr id="2" name="Rectangle 1"/>
+          <p:cNvSpPr/>
+          <p:nvPr/>
+        </p:nvSpPr>
+        <p:spPr>
+          <a:xfrm>
+            <a:off x="0" y="0"/>
+            <a:ext cx="12188952" cy="73152"/>
+          </a:xfrm>
+          <a:prstGeom prst="rect">
+            <a:avLst/>
+          </a:prstGeom>
+          <a:solidFill>
+            <a:srgbClr val="22627E"/>
+          </a:solidFill>
+          <a:ln>
+            <a:noFill/>
+          </a:ln>
+        </p:spPr>
+        <p:style>
+          <a:lnRef idx="1">
+            <a:schemeClr val="accent1"/>
+          </a:lnRef>
+          <a:fillRef idx="3">
+            <a:schemeClr val="accent1"/>
+          </a:fillRef>
+          <a:effectRef idx="2">
+            <a:schemeClr val="accent1"/>
+          </a:effectRef>
+          <a:fontRef idx="minor">
+            <a:schemeClr val="lt1"/>
+          </a:fontRef>
+        </p:style>
+        <p:txBody>
+          <a:bodyPr rtlCol="0" anchor="ctr"/>
+          <a:lstStyle/>
+          <a:p>
+            <a:pPr algn="ctr"/>
+          </a:p>
+        </p:txBody>
+      </p:sp>
+      <p:sp>
+        <p:nvSpPr>
+          <p:cNvPr id="3" name="TextBox 2"/>
+          <p:cNvSpPr txBox="1"/>
+          <p:nvPr/>
+        </p:nvSpPr>
+        <p:spPr>
+          <a:xfrm>
+            <a:off x="457200" y="274320"/>
+            <a:ext cx="10972800" cy="731520"/>
+          </a:xfrm>
+          <a:prstGeom prst="rect">
+            <a:avLst/>
+          </a:prstGeom>
+          <a:noFill/>
+        </p:spPr>
+        <p:txBody>
+          <a:bodyPr wrap="square"/>
+          <a:lstStyle/>
+          <a:p>
+            <a:pPr algn="l">
+              <a:defRPr sz="3200" b="1">
+                <a:solidFill>
+                  <a:srgbClr val="22627E"/>
+                </a:solidFill>
+                <a:latin typeface="Calibri"/>
+              </a:defRPr>
+            </a:pPr>
+            <a:r>
+              <a:t>Respuestas al repaso (2/2)</a:t>
+            </a:r>
+          </a:p>
+        </p:txBody>
+      </p:sp>
+      <p:sp>
+        <p:nvSpPr>
+          <p:cNvPr id="4" name="Rectangle 3"/>
+          <p:cNvSpPr/>
+          <p:nvPr/>
+        </p:nvSpPr>
+        <p:spPr>
+          <a:xfrm>
+            <a:off x="457200" y="1051560"/>
+            <a:ext cx="10972800" cy="27432"/>
+          </a:xfrm>
+          <a:prstGeom prst="rect">
+            <a:avLst/>
+          </a:prstGeom>
+          <a:solidFill>
+            <a:srgbClr val="22627E"/>
+          </a:solidFill>
+          <a:ln>
+            <a:noFill/>
+          </a:ln>
+        </p:spPr>
+        <p:style>
+          <a:lnRef idx="1">
+            <a:schemeClr val="accent1"/>
+          </a:lnRef>
+          <a:fillRef idx="3">
+            <a:schemeClr val="accent1"/>
+          </a:fillRef>
+          <a:effectRef idx="2">
+            <a:schemeClr val="accent1"/>
+          </a:effectRef>
+          <a:fontRef idx="minor">
+            <a:schemeClr val="lt1"/>
+          </a:fontRef>
+        </p:style>
+        <p:txBody>
+          <a:bodyPr rtlCol="0" anchor="ctr"/>
+          <a:lstStyle/>
+          <a:p>
+            <a:pPr algn="ctr"/>
+          </a:p>
+        </p:txBody>
+      </p:sp>
+      <p:sp>
+        <p:nvSpPr>
+          <p:cNvPr id="5" name="TextBox 4"/>
+          <p:cNvSpPr txBox="1"/>
+          <p:nvPr/>
+        </p:nvSpPr>
+        <p:spPr>
+          <a:xfrm>
+            <a:off x="640080" y="1280160"/>
+            <a:ext cx="10515600" cy="5029200"/>
+          </a:xfrm>
+          <a:prstGeom prst="rect">
+            <a:avLst/>
+          </a:prstGeom>
+          <a:noFill/>
+        </p:spPr>
+        <p:txBody>
+          <a:bodyPr wrap="square">
+            <a:spAutoFit/>
+          </a:bodyPr>
+          <a:lstStyle/>
+          <a:p>
+            <a:pPr>
+              <a:spcAft>
+                <a:spcPts val="800"/>
+              </a:spcAft>
+              <a:defRPr sz="2000">
+                <a:solidFill>
+                  <a:srgbClr val="333333"/>
+                </a:solidFill>
+                <a:latin typeface="Calibri"/>
+              </a:defRPr>
+            </a:pPr>
+            <a:r>
+              <a:t>4. Private Data Collections:</a:t>
+            </a:r>
+          </a:p>
+          <a:p>
+            <a:pPr lvl="1">
+              <a:spcAft>
+                <a:spcPts val="400"/>
+              </a:spcAft>
+              <a:defRPr sz="1700">
+                <a:solidFill>
+                  <a:srgbClr val="666666"/>
+                </a:solidFill>
+                <a:latin typeface="Calibri"/>
+              </a:defRPr>
+            </a:pPr>
+            <a:r>
+              <a:t>    Mecanismo para compartir datos solo entre un subconjunto de orgs del canal.</a:t>
+            </a:r>
+          </a:p>
+          <a:p>
+            <a:pPr lvl="1">
+              <a:spcAft>
+                <a:spcPts val="400"/>
+              </a:spcAft>
+              <a:defRPr sz="1700">
+                <a:solidFill>
+                  <a:srgbClr val="666666"/>
+                </a:solidFill>
+                <a:latin typeface="Calibri"/>
+              </a:defRPr>
+            </a:pPr>
+            <a:r>
+              <a:t>    Se definen en collections_config.json: nombre, policy, blockToLive, miembros.</a:t>
+            </a:r>
+          </a:p>
+          <a:p>
+            <a:pPr lvl="1">
+              <a:spcAft>
+                <a:spcPts val="400"/>
+              </a:spcAft>
+              <a:defRPr sz="1700">
+                <a:solidFill>
+                  <a:srgbClr val="666666"/>
+                </a:solidFill>
+                <a:latin typeface="Calibri"/>
+              </a:defRPr>
+            </a:pPr>
+            <a:r>
+              <a:t>    Ejemplo: priceAgreement visible solo entre comprador y vendedor, no otras orgs.</a:t>
+            </a:r>
+          </a:p>
+          <a:p>
+            <a:pPr>
+              <a:spcAft>
+                <a:spcPts val="800"/>
+              </a:spcAft>
+              <a:defRPr sz="2000">
+                <a:solidFill>
+                  <a:srgbClr val="333333"/>
+                </a:solidFill>
+                <a:latin typeface="Calibri"/>
+              </a:defRPr>
+            </a:pPr>
+            <a:r>
+              <a:t>5. Donde se almacenan datos privados vs hash:</a:t>
+            </a:r>
+          </a:p>
+          <a:p>
+            <a:pPr lvl="1">
+              <a:spcAft>
+                <a:spcPts val="400"/>
+              </a:spcAft>
+              <a:defRPr sz="1700">
+                <a:solidFill>
+                  <a:srgbClr val="666666"/>
+                </a:solidFill>
+                <a:latin typeface="Calibri"/>
+              </a:defRPr>
+            </a:pPr>
+            <a:r>
+              <a:t>    Datos privados: base de datos privada de cada peer autorizado (LevelDB/CouchDB del peer).</a:t>
+            </a:r>
+          </a:p>
+          <a:p>
+            <a:pPr lvl="1">
+              <a:spcAft>
+                <a:spcPts val="400"/>
+              </a:spcAft>
+              <a:defRPr sz="1700">
+                <a:solidFill>
+                  <a:srgbClr val="666666"/>
+                </a:solidFill>
+                <a:latin typeface="Calibri"/>
+              </a:defRPr>
+            </a:pPr>
+            <a:r>
+              <a:t>    Hash: en el ledger publico del canal, visible para TODAS las orgs.</a:t>
+            </a:r>
+          </a:p>
+          <a:p>
+            <a:pPr lvl="1">
+              <a:spcAft>
+                <a:spcPts val="400"/>
+              </a:spcAft>
+              <a:defRPr sz="1700">
+                <a:solidFill>
+                  <a:srgbClr val="666666"/>
+                </a:solidFill>
+                <a:latin typeface="Calibri"/>
+              </a:defRPr>
+            </a:pPr>
+            <a:r>
+              <a:t>    El hash garantiza integridad sin revelar el contenido.</a:t>
+            </a:r>
+          </a:p>
+          <a:p>
+            <a:pPr>
+              <a:spcAft>
+                <a:spcPts val="800"/>
+              </a:spcAft>
+              <a:defRPr sz="2000">
+                <a:solidFill>
+                  <a:srgbClr val="333333"/>
+                </a:solidFill>
+                <a:latin typeface="Calibri"/>
+              </a:defRPr>
+            </a:pPr>
+            <a:r>
+              <a:t>6. Emitir un evento desde chaincode:</a:t>
+            </a:r>
+          </a:p>
+          <a:p>
+            <a:pPr lvl="1">
+              <a:spcAft>
+                <a:spcPts val="400"/>
+              </a:spcAft>
+              <a:defRPr sz="1700">
+                <a:solidFill>
+                  <a:srgbClr val="666666"/>
+                </a:solidFill>
+                <a:latin typeface="Calibri"/>
+              </a:defRPr>
+            </a:pPr>
+            <a:r>
+              <a:t>    ctx.GetStub().SetEvent(nombreEvento, payloadBytes).</a:t>
+            </a:r>
+          </a:p>
+          <a:p>
+            <a:pPr lvl="1">
+              <a:spcAft>
+                <a:spcPts val="400"/>
+              </a:spcAft>
+              <a:defRPr sz="1700">
+                <a:solidFill>
+                  <a:srgbClr val="666666"/>
+                </a:solidFill>
+                <a:latin typeface="Calibri"/>
+              </a:defRPr>
+            </a:pPr>
+            <a:r>
+              <a:t>    Ejemplo: ctx.GetStub().SetEvent('PropertyTransferred', eventJSON).</a:t>
+            </a:r>
+          </a:p>
+          <a:p>
+            <a:pPr lvl="1">
+              <a:spcAft>
+                <a:spcPts val="400"/>
+              </a:spcAft>
+              <a:defRPr sz="1700">
+                <a:solidFill>
+                  <a:srgbClr val="666666"/>
+                </a:solidFill>
+                <a:latin typeface="Calibri"/>
+              </a:defRPr>
+            </a:pPr>
+            <a:r>
+              <a:t>    Los clientes se suscriben con contract.addContractListener() o peer channel events.</a:t>
+            </a:r>
+          </a:p>
+          <a:p>
+            <a:pPr>
+              <a:spcAft>
+                <a:spcPts val="800"/>
+              </a:spcAft>
+              <a:defRPr sz="2000">
+                <a:solidFill>
+                  <a:srgbClr val="333333"/>
+                </a:solidFill>
+                <a:latin typeface="Calibri"/>
+              </a:defRPr>
+            </a:pPr>
+            <a:r>
+              <a:t>7. Cuantos eventos por transaccion:</a:t>
+            </a:r>
+          </a:p>
+          <a:p>
+            <a:pPr lvl="1">
+              <a:spcAft>
+                <a:spcPts val="400"/>
+              </a:spcAft>
+              <a:defRPr sz="1700">
+                <a:solidFill>
+                  <a:srgbClr val="666666"/>
+                </a:solidFill>
+                <a:latin typeface="Calibri"/>
+              </a:defRPr>
+            </a:pPr>
+            <a:r>
+              <a:t>    SOLO UNO por transaccion. Si llamas SetEvent dos veces, solo el ultimo prevalece.</a:t>
+            </a:r>
+          </a:p>
+          <a:p>
+            <a:pPr lvl="1">
+              <a:spcAft>
+                <a:spcPts val="400"/>
+              </a:spcAft>
+              <a:defRPr sz="1700">
+                <a:solidFill>
+                  <a:srgbClr val="666666"/>
+                </a:solidFill>
+                <a:latin typeface="Calibri"/>
+              </a:defRPr>
+            </a:pPr>
+            <a:r>
+              <a:t>    Si necesitas notificar varias cosas, usa un JSON con multiples campos en el payload.</a:t>
+            </a:r>
+          </a:p>
+          <a:p>
+            <a:pPr lvl="1">
+              <a:spcAft>
+                <a:spcPts val="400"/>
+              </a:spcAft>
+              <a:defRPr sz="1700">
+                <a:solidFill>
+                  <a:srgbClr val="666666"/>
+                </a:solidFill>
+                <a:latin typeface="Calibri"/>
+              </a:defRPr>
+            </a:pPr>
+            <a:r>
+              <a:t>    Alternativa: emitir un evento generico con 'type' dentro que indique que ha pasado.</a:t>
             </a:r>
           </a:p>
         </p:txBody>

</xml_diff>